<commit_message>
Edited sources and completed and uploaded proposal video
</commit_message>
<xml_diff>
--- a/presentation/Project Proposal Presentation.pptx
+++ b/presentation/Project Proposal Presentation.pptx
@@ -5,19 +5,20 @@
     <p:sldMasterId id="2147483672" r:id="rId1"/>
   </p:sldMasterIdLst>
   <p:notesMasterIdLst>
-    <p:notesMasterId r:id="rId9"/>
+    <p:notesMasterId r:id="rId10"/>
   </p:notesMasterIdLst>
   <p:handoutMasterIdLst>
-    <p:handoutMasterId r:id="rId10"/>
+    <p:handoutMasterId r:id="rId11"/>
   </p:handoutMasterIdLst>
   <p:sldIdLst>
     <p:sldId id="256" r:id="rId2"/>
     <p:sldId id="261" r:id="rId3"/>
-    <p:sldId id="258" r:id="rId4"/>
-    <p:sldId id="259" r:id="rId5"/>
-    <p:sldId id="262" r:id="rId6"/>
-    <p:sldId id="263" r:id="rId7"/>
-    <p:sldId id="260" r:id="rId8"/>
+    <p:sldId id="264" r:id="rId4"/>
+    <p:sldId id="258" r:id="rId5"/>
+    <p:sldId id="259" r:id="rId6"/>
+    <p:sldId id="262" r:id="rId7"/>
+    <p:sldId id="263" r:id="rId8"/>
+    <p:sldId id="260" r:id="rId9"/>
   </p:sldIdLst>
   <p:sldSz cx="12192000" cy="6858000"/>
   <p:notesSz cx="6858000" cy="9144000"/>
@@ -9842,7 +9843,7 @@
             <a:pPr rtl="0"/>
             <a:fld id="{3ADBC529-8773-4D02-8CFA-ADB515C5CBA3}" type="datetime1">
               <a:rPr lang="en-GB" smtClean="0"/>
-              <a:t>16/05/2026</a:t>
+              <a:t>17/05/2026</a:t>
             </a:fld>
             <a:endParaRPr lang="en-GB"/>
           </a:p>
@@ -10024,7 +10025,7 @@
             <a:pPr rtl="0"/>
             <a:fld id="{4777525A-FAFB-4452-AC36-0F7189B7A6A9}" type="datetime1">
               <a:rPr lang="en-GB" noProof="0" smtClean="0"/>
-              <a:t>16/05/2026</a:t>
+              <a:t>17/05/2026</a:t>
             </a:fld>
             <a:endParaRPr lang="en-GB" noProof="0"/>
           </a:p>
@@ -10440,7 +10441,7 @@
                 <a:ea typeface="+mn-ea"/>
                 <a:cs typeface="+mn-cs"/>
               </a:rPr>
-              <a:t>I am a teacher and personally understand the stressful, time-consuming ordeal that my colleagues and I must endure when marking answers to open-ended questions. It is impossible to remove bias and inconsistency from the marking process due to inherent human traits. There is also no provision besides an assigned scribe being made available to cater to students who can speak but are unable to write or type due to disability. This arrangement although well intentioned, is time consuming and intimidating to some students</a:t>
+              <a:t>I am a teacher and personally understand the stressful, time-consuming ordeal that my colleagues and I must endure when marking answers to open-ended questions. It is impossible to remove bias and inconsistency from the marking process due to inherent human traits. There is also no provision besides an assigned scribe being made available to cater to students who can speak but are unable to write or type due to disability. This arrangement although well intentioned, is time consuming and intimidating to some students. </a:t>
             </a:r>
             <a:endParaRPr lang="en-GB" dirty="0"/>
           </a:p>
@@ -10537,11 +10538,20 @@
                 <a:ea typeface="+mn-ea"/>
                 <a:cs typeface="+mn-cs"/>
               </a:rPr>
-              <a:t>[1] divided AES systems into two categories:</a:t>
+              <a:t>Lagakis and </a:t>
             </a:r>
-          </a:p>
-          <a:p>
-            <a:pPr lvl="0"/>
+            <a:r>
+              <a:rPr lang="en-GB" sz="1200" kern="1200" dirty="0" err="1">
+                <a:solidFill>
+                  <a:schemeClr val="tx1"/>
+                </a:solidFill>
+                <a:effectLst/>
+                <a:latin typeface="+mn-lt"/>
+                <a:ea typeface="+mn-ea"/>
+                <a:cs typeface="+mn-cs"/>
+              </a:rPr>
+              <a:t>Demetriadis</a:t>
+            </a:r>
             <a:r>
               <a:rPr lang="en-GB" sz="1200" kern="1200" dirty="0">
                 <a:solidFill>
@@ -10552,11 +10562,14 @@
                 <a:ea typeface="+mn-ea"/>
                 <a:cs typeface="+mn-cs"/>
               </a:rPr>
-              <a:t>Systems that use feature engineering models with handcrafted features</a:t>
+              <a:t> (2021) divided AES systems into two categories:</a:t>
             </a:r>
           </a:p>
           <a:p>
-            <a:pPr lvl="0"/>
+            <a:pPr marL="171450" lvl="0" indent="-171450">
+              <a:buFont typeface="Arial" panose="020B0604020202020204" pitchFamily="34" charset="0"/>
+              <a:buChar char="•"/>
+            </a:pPr>
             <a:r>
               <a:rPr lang="en-GB" sz="1200" kern="1200" dirty="0">
                 <a:solidFill>
@@ -10567,7 +10580,25 @@
                 <a:ea typeface="+mn-ea"/>
                 <a:cs typeface="+mn-cs"/>
               </a:rPr>
-              <a:t>Systems with neural approaches that can extract features automatically </a:t>
+              <a:t>Those using feature engineering models with handcrafted features</a:t>
+            </a:r>
+          </a:p>
+          <a:p>
+            <a:pPr marL="171450" lvl="0" indent="-171450">
+              <a:buFont typeface="Arial" panose="020B0604020202020204" pitchFamily="34" charset="0"/>
+              <a:buChar char="•"/>
+            </a:pPr>
+            <a:r>
+              <a:rPr lang="en-GB" sz="1200" kern="1200" dirty="0">
+                <a:solidFill>
+                  <a:schemeClr val="tx1"/>
+                </a:solidFill>
+                <a:effectLst/>
+                <a:latin typeface="+mn-lt"/>
+                <a:ea typeface="+mn-ea"/>
+                <a:cs typeface="+mn-cs"/>
+              </a:rPr>
+              <a:t>Those with neural approaches that can extract features automatically </a:t>
             </a:r>
           </a:p>
           <a:p>
@@ -10598,7 +10629,31 @@
                 <a:ea typeface="+mn-ea"/>
                 <a:cs typeface="+mn-cs"/>
               </a:rPr>
-              <a:t>[1] Project Essay Grader TM (PEG) used supervised learning with linear regression and leveraged the benefits of handcrafted features. The E-Rater system [3] employed linear regression to identify crucial features for predicting essay scores. [2] indicated that reliance on surface-level textual features such as sentence length and word frequency, limited handmade systems in capturing semantic meaning and conceptual quality. [5] concluded that although the deep learning-based systems performed better overall, improvement with respect to modelling complex linguistic and cognitive qualities inherent in essays was not significant. .  [4] carried out a comparative study on the performance of LSTM, Bi-LSTM and BERT and concluded that BERT demonstrated superior performance. [6] transformer-based models have better scoring accuracy due to their ability to analyse text more thoroughly interpreting connections between words even when they are not in proximity. </a:t>
+              <a:t>According to these researchers, Project Essay Grader TM (PEG), an early AES system used supervised learning with linear regression and leveraged the benefits of handcrafted features. Yang (2024) also described the E-Rater system as employing similar methods. Yang also indicated that reliance on surface-level textual features such as sentence length and word frequency, limited handmade systems in capturing semantic meaning and conceptual quality. Mahmud and Hoo (2024) concluded that the performance of deep learning models with respect to modelling complex linguistic and cognitive qualities inherent in essays was not significant. Han and Myint (2024) carried out a comparative study on the performance of LSTM, Bi-LSTM and BERT and concluded that BERT, a transformer model, demonstrated superior performance. </a:t>
+            </a:r>
+            <a:r>
+              <a:rPr lang="en-GB" sz="1200" kern="1200" dirty="0" err="1">
+                <a:solidFill>
+                  <a:schemeClr val="tx1"/>
+                </a:solidFill>
+                <a:effectLst/>
+                <a:latin typeface="+mn-lt"/>
+                <a:ea typeface="+mn-ea"/>
+                <a:cs typeface="+mn-cs"/>
+              </a:rPr>
+              <a:t>Elmassry</a:t>
+            </a:r>
+            <a:r>
+              <a:rPr lang="en-GB" sz="1200" kern="1200" dirty="0">
+                <a:solidFill>
+                  <a:schemeClr val="tx1"/>
+                </a:solidFill>
+                <a:effectLst/>
+                <a:latin typeface="+mn-lt"/>
+                <a:ea typeface="+mn-ea"/>
+                <a:cs typeface="+mn-cs"/>
+              </a:rPr>
+              <a:t> et al. (2025) commented on  transformer-based models as having better scoring accuracy due to their ability to analyse text more thoroughly interpreting connections between words even when they are not in proximity. </a:t>
             </a:r>
           </a:p>
           <a:p>
@@ -10624,7 +10679,7 @@
             <a:pPr rtl="0"/>
             <a:fld id="{C6B3AB32-59DF-41F1-9618-EDFBF5049629}" type="slidenum">
               <a:rPr lang="en-GB" smtClean="0"/>
-              <a:t>3</a:t>
+              <a:t>4</a:t>
             </a:fld>
             <a:endParaRPr lang="en-GB"/>
           </a:p>
@@ -10714,7 +10769,55 @@
                 <a:ea typeface="+mn-ea"/>
                 <a:cs typeface="+mn-cs"/>
               </a:rPr>
-              <a:t>Studies such as [1] have indicated that aspects of an essay that refer to its content quality, such as coherence and persuasiveness are still very difficult to be effectively estimated even by an AES system. Even after extensive research spanning more than two decades in AES, no single model has achieved near-perfect accuracy in scoring sufficient to replace human scorers. Consequently, AES remains an open research problem. [1] suggests not relying solely on transformer models and like [2], proposed a technique of combining transformers with more traditional approaches like those that employ handcrafted features. [2] indicated that when models work in combination the results are more promising. [7] used a hybrid model – LSTM and Word Embedding and achieved a QWK of 0.94. </a:t>
+              <a:t>Even after extensive research spanning more than two decades in AES, no single model has achieved near-perfect accuracy in scoring sufficient to replace human scorers. Consequently, AES remains an open research problem. Lagakis and </a:t>
+            </a:r>
+            <a:r>
+              <a:rPr lang="en-GB" sz="1200" kern="1200" dirty="0" err="1">
+                <a:solidFill>
+                  <a:schemeClr val="tx1"/>
+                </a:solidFill>
+                <a:effectLst/>
+                <a:latin typeface="+mn-lt"/>
+                <a:ea typeface="+mn-ea"/>
+                <a:cs typeface="+mn-cs"/>
+              </a:rPr>
+              <a:t>Demetriadis</a:t>
+            </a:r>
+            <a:r>
+              <a:rPr lang="en-GB" sz="1200" kern="1200" dirty="0">
+                <a:solidFill>
+                  <a:schemeClr val="tx1"/>
+                </a:solidFill>
+                <a:effectLst/>
+                <a:latin typeface="+mn-lt"/>
+                <a:ea typeface="+mn-ea"/>
+                <a:cs typeface="+mn-cs"/>
+              </a:rPr>
+              <a:t> suggests not relying solely on transformer models and like Artha et al. (2026) proposed a technique of combining transformers with more traditional approaches like those that employ handcrafted features. Artha et al. indicated that when models work in combination the results are more promising. </a:t>
+            </a:r>
+            <a:r>
+              <a:rPr lang="en-GB" sz="1200" kern="1200" dirty="0" err="1">
+                <a:solidFill>
+                  <a:schemeClr val="tx1"/>
+                </a:solidFill>
+                <a:effectLst/>
+                <a:latin typeface="+mn-lt"/>
+                <a:ea typeface="+mn-ea"/>
+                <a:cs typeface="+mn-cs"/>
+              </a:rPr>
+              <a:t>Chimingyang</a:t>
+            </a:r>
+            <a:r>
+              <a:rPr lang="en-GB" sz="1200" kern="1200" dirty="0">
+                <a:solidFill>
+                  <a:schemeClr val="tx1"/>
+                </a:solidFill>
+                <a:effectLst/>
+                <a:latin typeface="+mn-lt"/>
+                <a:ea typeface="+mn-ea"/>
+                <a:cs typeface="+mn-cs"/>
+              </a:rPr>
+              <a:t> (2020) used a hybrid model – LSTM and Word Embedding and achieved a Quadratic Weighted Kappa (QWK) score of 0.94. </a:t>
             </a:r>
           </a:p>
           <a:p>
@@ -10741,7 +10844,7 @@
             <a:pPr rtl="0"/>
             <a:fld id="{C6B3AB32-59DF-41F1-9618-EDFBF5049629}" type="slidenum">
               <a:rPr lang="en-GB" smtClean="0"/>
-              <a:t>4</a:t>
+              <a:t>5</a:t>
             </a:fld>
             <a:endParaRPr lang="en-GB"/>
           </a:p>
@@ -10832,7 +10935,7 @@
                 <a:ea typeface="+mn-ea"/>
                 <a:cs typeface="+mn-cs"/>
               </a:rPr>
-              <a:t>Therefore, this research proposes a hybrid approach, supported by the conclusion reached by [1], [2] and [7] after evaluating the performance of stand-alone models in comparison to them. This proposed model will leverage the capabilities of three pretrained models:</a:t>
+              <a:t>Therefore, this research proposes a hybrid approach, supported by the conclusion reached by three of the previously cited researchers after evaluating the performance of stand-alone models in comparison to them. This proposed model will leverage the capabilities of three pretrained models:</a:t>
             </a:r>
           </a:p>
           <a:p>
@@ -10861,7 +10964,7 @@
                 <a:ea typeface="+mn-ea"/>
                 <a:cs typeface="+mn-cs"/>
               </a:rPr>
-              <a:t>A speech-to-text model: to capture answers provided in audio format and convert these to digital text for analysis by the AES system for evaluation. The researcher envisages will assist students who are unable to write but have the capacity to verbally express themselves allowing for equal opportunity in the classroom. </a:t>
+              <a:t>A speech-to-text model: to capture answers provided in audio format and convert these to digital text for analysis by the AES system for evaluation. This will capture verbal expression allowing for equal opportunity in the classroom. </a:t>
             </a:r>
           </a:p>
           <a:p>
@@ -10879,7 +10982,7 @@
                 <a:ea typeface="+mn-ea"/>
                 <a:cs typeface="+mn-cs"/>
               </a:rPr>
-              <a:t>An image-to-text model: to perform optical character recognition from scanned documents or textual data from images for analysis by the AES system. Even with technological advancements, it is unlikely that handwriting will ever become outdated or obsolete. </a:t>
+              <a:t>An image-to-text model: to perform optical character recognition from scanned documents or textual data from images for analysis by the AES system. Catering to written documents. </a:t>
             </a:r>
           </a:p>
           <a:p>
@@ -10901,9 +11004,42 @@
             </a:r>
           </a:p>
           <a:p>
-            <a:pPr marL="171450" lvl="0" indent="-171450">
+            <a:pPr marL="0" lvl="0" indent="0">
               <a:buFont typeface="Arial" panose="020B0604020202020204" pitchFamily="34" charset="0"/>
-              <a:buChar char="•"/>
+              <a:buNone/>
+            </a:pPr>
+            <a:endParaRPr lang="en-GB" sz="1200" kern="1200" dirty="0">
+              <a:solidFill>
+                <a:schemeClr val="tx1"/>
+              </a:solidFill>
+              <a:effectLst/>
+              <a:latin typeface="+mn-lt"/>
+              <a:ea typeface="+mn-ea"/>
+              <a:cs typeface="+mn-cs"/>
+            </a:endParaRPr>
+          </a:p>
+          <a:p>
+            <a:pPr marL="0" lvl="0" indent="0">
+              <a:buFont typeface="Arial" panose="020B0604020202020204" pitchFamily="34" charset="0"/>
+              <a:buNone/>
+            </a:pPr>
+            <a:r>
+              <a:rPr lang="en-GB" sz="1200" kern="1200" dirty="0">
+                <a:solidFill>
+                  <a:schemeClr val="tx1"/>
+                </a:solidFill>
+                <a:effectLst/>
+                <a:latin typeface="+mn-lt"/>
+                <a:ea typeface="+mn-ea"/>
+                <a:cs typeface="+mn-cs"/>
+              </a:rPr>
+              <a:t>The Workflow: </a:t>
+            </a:r>
+          </a:p>
+          <a:p>
+            <a:pPr marL="0" lvl="0" indent="0">
+              <a:buFont typeface="Arial" panose="020B0604020202020204" pitchFamily="34" charset="0"/>
+              <a:buNone/>
             </a:pPr>
             <a:endParaRPr lang="en-GB" sz="1200" kern="1200" dirty="0">
               <a:solidFill>
@@ -10959,7 +11095,7 @@
             <a:pPr rtl="0"/>
             <a:fld id="{C6B3AB32-59DF-41F1-9618-EDFBF5049629}" type="slidenum">
               <a:rPr lang="en-GB" smtClean="0"/>
-              <a:t>5</a:t>
+              <a:t>6</a:t>
             </a:fld>
             <a:endParaRPr lang="en-GB"/>
           </a:p>
@@ -11019,6 +11155,91 @@
         </p:nvSpPr>
         <p:spPr/>
         <p:txBody>
+          <a:bodyPr/>
+          <a:lstStyle/>
+          <a:p>
+            <a:endParaRPr lang="en-GB" dirty="0"/>
+          </a:p>
+        </p:txBody>
+      </p:sp>
+      <p:sp>
+        <p:nvSpPr>
+          <p:cNvPr id="4" name="Slide Number Placeholder 3"/>
+          <p:cNvSpPr>
+            <a:spLocks noGrp="1"/>
+          </p:cNvSpPr>
+          <p:nvPr>
+            <p:ph type="sldNum" sz="quarter" idx="5"/>
+          </p:nvPr>
+        </p:nvSpPr>
+        <p:spPr/>
+        <p:txBody>
+          <a:bodyPr/>
+          <a:lstStyle/>
+          <a:p>
+            <a:pPr rtl="0"/>
+            <a:fld id="{C6B3AB32-59DF-41F1-9618-EDFBF5049629}" type="slidenum">
+              <a:rPr lang="en-GB" noProof="0" smtClean="0"/>
+              <a:t>7</a:t>
+            </a:fld>
+            <a:endParaRPr lang="en-GB" noProof="0"/>
+          </a:p>
+        </p:txBody>
+      </p:sp>
+    </p:spTree>
+    <p:extLst>
+      <p:ext uri="{BB962C8B-B14F-4D97-AF65-F5344CB8AC3E}">
+        <p14:creationId xmlns:p14="http://schemas.microsoft.com/office/powerpoint/2010/main" val="3699205223"/>
+      </p:ext>
+    </p:extLst>
+  </p:cSld>
+  <p:clrMapOvr>
+    <a:masterClrMapping/>
+  </p:clrMapOvr>
+</p:notes>
+</file>
+
+<file path=ppt/notesSlides/notesSlide7.xml><?xml version="1.0" encoding="utf-8"?>
+<p:notes xmlns:a="http://schemas.openxmlformats.org/drawingml/2006/main" xmlns:r="http://schemas.openxmlformats.org/officeDocument/2006/relationships" xmlns:p="http://schemas.openxmlformats.org/presentationml/2006/main">
+  <p:cSld>
+    <p:spTree>
+      <p:nvGrpSpPr>
+        <p:cNvPr id="1" name=""/>
+        <p:cNvGrpSpPr/>
+        <p:nvPr/>
+      </p:nvGrpSpPr>
+      <p:grpSpPr>
+        <a:xfrm>
+          <a:off x="0" y="0"/>
+          <a:ext cx="0" cy="0"/>
+          <a:chOff x="0" y="0"/>
+          <a:chExt cx="0" cy="0"/>
+        </a:xfrm>
+      </p:grpSpPr>
+      <p:sp>
+        <p:nvSpPr>
+          <p:cNvPr id="2" name="Slide Image Placeholder 1"/>
+          <p:cNvSpPr>
+            <a:spLocks noGrp="1" noRot="1" noChangeAspect="1"/>
+          </p:cNvSpPr>
+          <p:nvPr>
+            <p:ph type="sldImg"/>
+          </p:nvPr>
+        </p:nvSpPr>
+        <p:spPr/>
+      </p:sp>
+      <p:sp>
+        <p:nvSpPr>
+          <p:cNvPr id="3" name="Notes Placeholder 2"/>
+          <p:cNvSpPr>
+            <a:spLocks noGrp="1"/>
+          </p:cNvSpPr>
+          <p:nvPr>
+            <p:ph type="body" idx="1"/>
+          </p:nvPr>
+        </p:nvSpPr>
+        <p:spPr/>
+        <p:txBody>
           <a:bodyPr rtlCol="0"/>
           <a:lstStyle/>
           <a:p>
@@ -11045,7 +11266,7 @@
             <a:pPr rtl="0"/>
             <a:fld id="{C6B3AB32-59DF-41F1-9618-EDFBF5049629}" type="slidenum">
               <a:rPr lang="en-GB" smtClean="0"/>
-              <a:t>7</a:t>
+              <a:t>8</a:t>
             </a:fld>
             <a:endParaRPr lang="en-GB"/>
           </a:p>
@@ -11319,7 +11540,7 @@
             <a:pPr rtl="0"/>
             <a:fld id="{303A4E85-D1CF-4174-8E96-0E716FE67106}" type="datetime1">
               <a:rPr lang="en-GB" noProof="0" smtClean="0"/>
-              <a:t>16/05/2026</a:t>
+              <a:t>17/05/2026</a:t>
             </a:fld>
             <a:endParaRPr lang="en-GB" noProof="0"/>
           </a:p>
@@ -11585,7 +11806,7 @@
             <a:pPr rtl="0"/>
             <a:fld id="{6EBFDA4C-4741-4614-8CF1-6BBCA681C2EE}" type="datetime1">
               <a:rPr lang="en-GB" noProof="0" smtClean="0"/>
-              <a:t>16/05/2026</a:t>
+              <a:t>17/05/2026</a:t>
             </a:fld>
             <a:endParaRPr lang="en-GB" noProof="0"/>
           </a:p>
@@ -11824,7 +12045,7 @@
             <a:pPr rtl="0"/>
             <a:fld id="{0663A167-FB84-446A-9868-9338781AA304}" type="datetime1">
               <a:rPr lang="en-GB" noProof="0" smtClean="0"/>
-              <a:t>16/05/2026</a:t>
+              <a:t>17/05/2026</a:t>
             </a:fld>
             <a:endParaRPr lang="en-GB" noProof="0"/>
           </a:p>
@@ -12075,7 +12296,7 @@
             <a:pPr rtl="0"/>
             <a:fld id="{E3DCA11A-9768-448A-88A0-EBE3646E26CE}" type="datetime1">
               <a:rPr lang="en-GB" noProof="0" smtClean="0"/>
-              <a:t>16/05/2026</a:t>
+              <a:t>17/05/2026</a:t>
             </a:fld>
             <a:endParaRPr lang="en-GB" noProof="0"/>
           </a:p>
@@ -12387,7 +12608,7 @@
             <a:pPr rtl="0"/>
             <a:fld id="{1FEDAE78-A3F9-426C-8A41-9692E3443471}" type="datetime1">
               <a:rPr lang="en-GB" noProof="0" smtClean="0"/>
-              <a:t>16/05/2026</a:t>
+              <a:t>17/05/2026</a:t>
             </a:fld>
             <a:endParaRPr lang="en-GB" noProof="0"/>
           </a:p>
@@ -12699,7 +12920,7 @@
             <a:pPr rtl="0"/>
             <a:fld id="{E17F9CBD-9AAB-4D08-A1FC-12CB5054CF84}" type="datetime1">
               <a:rPr lang="en-GB" noProof="0" smtClean="0"/>
-              <a:t>16/05/2026</a:t>
+              <a:t>17/05/2026</a:t>
             </a:fld>
             <a:endParaRPr lang="en-GB" noProof="0"/>
           </a:p>
@@ -13124,7 +13345,7 @@
             <a:pPr rtl="0"/>
             <a:fld id="{A9E97160-1FA1-4003-9894-A2FDBE217EB3}" type="datetime1">
               <a:rPr lang="en-GB" noProof="0" smtClean="0"/>
-              <a:t>16/05/2026</a:t>
+              <a:t>17/05/2026</a:t>
             </a:fld>
             <a:endParaRPr lang="en-GB" noProof="0"/>
           </a:p>
@@ -13223,7 +13444,7 @@
             <a:pPr rtl="0"/>
             <a:fld id="{25F76C7B-B428-4E1D-8DC1-C83A59B39C9C}" type="datetime1">
               <a:rPr lang="en-GB" noProof="0" smtClean="0"/>
-              <a:t>16/05/2026</a:t>
+              <a:t>17/05/2026</a:t>
             </a:fld>
             <a:endParaRPr lang="en-GB" noProof="0"/>
           </a:p>
@@ -13390,7 +13611,7 @@
             <a:pPr rtl="0"/>
             <a:fld id="{89227842-69A9-4D57-8696-571A640FF47C}" type="datetime1">
               <a:rPr lang="en-GB" noProof="0" smtClean="0"/>
-              <a:t>16/05/2026</a:t>
+              <a:t>17/05/2026</a:t>
             </a:fld>
             <a:endParaRPr lang="en-GB" noProof="0"/>
           </a:p>
@@ -13772,7 +13993,7 @@
             <a:pPr rtl="0"/>
             <a:fld id="{B6D4024D-709A-489C-A1E0-404FC4EC40E9}" type="datetime1">
               <a:rPr lang="en-GB" noProof="0" smtClean="0"/>
-              <a:t>16/05/2026</a:t>
+              <a:t>17/05/2026</a:t>
             </a:fld>
             <a:endParaRPr lang="en-GB" noProof="0"/>
           </a:p>
@@ -14067,7 +14288,7 @@
             <a:pPr rtl="0"/>
             <a:fld id="{5FFEA7D9-67F6-4FDA-9663-2C4F43E353A1}" type="datetime1">
               <a:rPr lang="en-GB" noProof="0" smtClean="0"/>
-              <a:t>16/05/2026</a:t>
+              <a:t>17/05/2026</a:t>
             </a:fld>
             <a:endParaRPr lang="en-GB" noProof="0"/>
           </a:p>
@@ -14283,7 +14504,7 @@
             <a:pPr rtl="0"/>
             <a:fld id="{4B4B326D-8F15-4B53-B18E-44A3026066F3}" type="datetime1">
               <a:rPr lang="en-GB" noProof="0" smtClean="0"/>
-              <a:t>16/05/2026</a:t>
+              <a:t>17/05/2026</a:t>
             </a:fld>
             <a:endParaRPr lang="en-GB" noProof="0"/>
           </a:p>
@@ -15564,6 +15785,14 @@
           <a:p>
             <a:pPr rtl="0"/>
             <a:r>
+              <a:rPr lang="en-GB" dirty="0">
+                <a:solidFill>
+                  <a:srgbClr val="FFFEFF"/>
+                </a:solidFill>
+              </a:rPr>
+              <a:t>The </a:t>
+            </a:r>
+            <a:r>
               <a:rPr lang="en-GB" dirty="0" err="1">
                 <a:solidFill>
                   <a:srgbClr val="FFFEFF"/>
@@ -15571,11 +15800,14 @@
               </a:rPr>
               <a:t>pROBLEM</a:t>
             </a:r>
-            <a:endParaRPr lang="en-GB" dirty="0">
-              <a:solidFill>
-                <a:srgbClr val="FFFEFF"/>
-              </a:solidFill>
-            </a:endParaRPr>
+            <a:r>
+              <a:rPr lang="en-GB" dirty="0">
+                <a:solidFill>
+                  <a:srgbClr val="FFFEFF"/>
+                </a:solidFill>
+              </a:rPr>
+              <a:t>(s)</a:t>
+            </a:r>
           </a:p>
         </p:txBody>
       </p:sp>
@@ -15792,6 +16024,94 @@
           <p:cNvPr id="2" name="Title 1">
             <a:extLst>
               <a:ext uri="{FF2B5EF4-FFF2-40B4-BE49-F238E27FC236}">
+                <a16:creationId xmlns:a16="http://schemas.microsoft.com/office/drawing/2014/main" id="{F5228491-18E0-0274-CD1A-565FC4E3FF29}"/>
+              </a:ext>
+            </a:extLst>
+          </p:cNvPr>
+          <p:cNvSpPr>
+            <a:spLocks noGrp="1"/>
+          </p:cNvSpPr>
+          <p:nvPr>
+            <p:ph type="title"/>
+          </p:nvPr>
+        </p:nvSpPr>
+        <p:spPr/>
+        <p:txBody>
+          <a:bodyPr/>
+          <a:lstStyle/>
+          <a:p>
+            <a:r>
+              <a:rPr lang="en-US" dirty="0"/>
+              <a:t>Proposed Solution</a:t>
+            </a:r>
+            <a:endParaRPr lang="en-GB" dirty="0"/>
+          </a:p>
+        </p:txBody>
+      </p:sp>
+      <p:sp>
+        <p:nvSpPr>
+          <p:cNvPr id="3" name="Content Placeholder 2">
+            <a:extLst>
+              <a:ext uri="{FF2B5EF4-FFF2-40B4-BE49-F238E27FC236}">
+                <a16:creationId xmlns:a16="http://schemas.microsoft.com/office/drawing/2014/main" id="{896E534E-0994-5DEA-71B7-96CD9F1AE8B3}"/>
+              </a:ext>
+            </a:extLst>
+          </p:cNvPr>
+          <p:cNvSpPr>
+            <a:spLocks noGrp="1"/>
+          </p:cNvSpPr>
+          <p:nvPr>
+            <p:ph idx="1"/>
+          </p:nvPr>
+        </p:nvSpPr>
+        <p:spPr/>
+        <p:txBody>
+          <a:bodyPr/>
+          <a:lstStyle/>
+          <a:p>
+            <a:r>
+              <a:rPr lang="en-US" dirty="0"/>
+              <a:t>An Automated Essay Scoring (AES) that is accessible to all students</a:t>
+            </a:r>
+            <a:endParaRPr lang="en-GB" dirty="0"/>
+          </a:p>
+        </p:txBody>
+      </p:sp>
+    </p:spTree>
+    <p:extLst>
+      <p:ext uri="{BB962C8B-B14F-4D97-AF65-F5344CB8AC3E}">
+        <p14:creationId xmlns:p14="http://schemas.microsoft.com/office/powerpoint/2010/main" val="744113047"/>
+      </p:ext>
+    </p:extLst>
+  </p:cSld>
+  <p:clrMapOvr>
+    <a:masterClrMapping/>
+  </p:clrMapOvr>
+</p:sld>
+</file>
+
+<file path=ppt/slides/slide4.xml><?xml version="1.0" encoding="utf-8"?>
+<p:sld xmlns:a="http://schemas.openxmlformats.org/drawingml/2006/main" xmlns:r="http://schemas.openxmlformats.org/officeDocument/2006/relationships" xmlns:p="http://schemas.openxmlformats.org/presentationml/2006/main">
+  <p:cSld>
+    <p:spTree>
+      <p:nvGrpSpPr>
+        <p:cNvPr id="1" name=""/>
+        <p:cNvGrpSpPr/>
+        <p:nvPr/>
+      </p:nvGrpSpPr>
+      <p:grpSpPr>
+        <a:xfrm>
+          <a:off x="0" y="0"/>
+          <a:ext cx="0" cy="0"/>
+          <a:chOff x="0" y="0"/>
+          <a:chExt cx="0" cy="0"/>
+        </a:xfrm>
+      </p:grpSpPr>
+      <p:sp>
+        <p:nvSpPr>
+          <p:cNvPr id="2" name="Title 1">
+            <a:extLst>
+              <a:ext uri="{FF2B5EF4-FFF2-40B4-BE49-F238E27FC236}">
                 <a16:creationId xmlns:a16="http://schemas.microsoft.com/office/drawing/2014/main" id="{921633EB-7DCB-4DDC-80AF-C885A3EE1245}"/>
               </a:ext>
             </a:extLst>
@@ -16174,7 +16494,7 @@
 </p:sld>
 </file>
 
-<file path=ppt/slides/slide4.xml><?xml version="1.0" encoding="utf-8"?>
+<file path=ppt/slides/slide5.xml><?xml version="1.0" encoding="utf-8"?>
 <p:sld xmlns:a="http://schemas.openxmlformats.org/drawingml/2006/main" xmlns:r="http://schemas.openxmlformats.org/officeDocument/2006/relationships" xmlns:p="http://schemas.openxmlformats.org/presentationml/2006/main">
   <p:cSld>
     <p:bg>
@@ -16591,7 +16911,7 @@
 </p:sld>
 </file>
 
-<file path=ppt/slides/slide5.xml><?xml version="1.0" encoding="utf-8"?>
+<file path=ppt/slides/slide6.xml><?xml version="1.0" encoding="utf-8"?>
 <p:sld xmlns:a="http://schemas.openxmlformats.org/drawingml/2006/main" xmlns:r="http://schemas.openxmlformats.org/officeDocument/2006/relationships" xmlns:p="http://schemas.openxmlformats.org/presentationml/2006/main">
   <p:cSld>
     <p:bg>
@@ -17067,7 +17387,7 @@
 </p:sld>
 </file>
 
-<file path=ppt/slides/slide6.xml><?xml version="1.0" encoding="utf-8"?>
+<file path=ppt/slides/slide7.xml><?xml version="1.0" encoding="utf-8"?>
 <p:sld xmlns:a="http://schemas.openxmlformats.org/drawingml/2006/main" xmlns:r="http://schemas.openxmlformats.org/officeDocument/2006/relationships" xmlns:p="http://schemas.openxmlformats.org/presentationml/2006/main">
   <p:cSld>
     <p:spTree>
@@ -17113,6 +17433,232 @@
           </a:p>
         </p:txBody>
       </p:sp>
+      <p:sp>
+        <p:nvSpPr>
+          <p:cNvPr id="3" name="TextBox 2">
+            <a:extLst>
+              <a:ext uri="{FF2B5EF4-FFF2-40B4-BE49-F238E27FC236}">
+                <a16:creationId xmlns:a16="http://schemas.microsoft.com/office/drawing/2014/main" id="{184E854E-2E52-4B33-54A6-DD4053F67BB5}"/>
+              </a:ext>
+            </a:extLst>
+          </p:cNvPr>
+          <p:cNvSpPr txBox="1"/>
+          <p:nvPr/>
+        </p:nvSpPr>
+        <p:spPr>
+          <a:xfrm>
+            <a:off x="308474" y="1902286"/>
+            <a:ext cx="11408038" cy="4801314"/>
+          </a:xfrm>
+          <a:prstGeom prst="rect">
+            <a:avLst/>
+          </a:prstGeom>
+          <a:noFill/>
+        </p:spPr>
+        <p:txBody>
+          <a:bodyPr wrap="square" rtlCol="0">
+            <a:spAutoFit/>
+          </a:bodyPr>
+          <a:lstStyle/>
+          <a:p>
+            <a:r>
+              <a:rPr lang="en-GB" dirty="0"/>
+              <a:t>[1] P. Lagakis and S. </a:t>
+            </a:r>
+            <a:r>
+              <a:rPr lang="en-GB" dirty="0" err="1"/>
+              <a:t>Demetriadis</a:t>
+            </a:r>
+            <a:r>
+              <a:rPr lang="en-GB" dirty="0"/>
+              <a:t>, “Automated essay scoring: A review of the field,” in </a:t>
+            </a:r>
+            <a:r>
+              <a:rPr lang="en-GB" i="1" dirty="0"/>
+              <a:t>2021 International Conference on Computer, Information and Telecommunication Systems (CITS)</a:t>
+            </a:r>
+            <a:r>
+              <a:rPr lang="en-GB" dirty="0"/>
+              <a:t>, 2021, </a:t>
+            </a:r>
+            <a:r>
+              <a:rPr lang="en-GB" dirty="0" err="1"/>
+              <a:t>doi</a:t>
+            </a:r>
+            <a:r>
+              <a:rPr lang="en-GB" dirty="0"/>
+              <a:t>: 10.1109/CITS52676.2021.9618476.</a:t>
+            </a:r>
+          </a:p>
+          <a:p>
+            <a:r>
+              <a:rPr lang="en-GB" dirty="0"/>
+              <a:t>[2] I. M. G. S. Artha, A. S. Kusuma, and P. </a:t>
+            </a:r>
+            <a:r>
+              <a:rPr lang="en-GB" dirty="0" err="1"/>
+              <a:t>Sugiartawan</a:t>
+            </a:r>
+            <a:r>
+              <a:rPr lang="en-GB" dirty="0"/>
+              <a:t>, “A comparative study of semantic similarity, rubric-based, generative AI, and hybrid scoring methods for automated essay evaluation,” in </a:t>
+            </a:r>
+            <a:r>
+              <a:rPr lang="en-GB" i="1" dirty="0"/>
+              <a:t>2026 International Seminar on Intelligent Business and Edge-Computing Research (ISIBER)</a:t>
+            </a:r>
+            <a:r>
+              <a:rPr lang="en-GB" dirty="0"/>
+              <a:t>, 2026, </a:t>
+            </a:r>
+            <a:r>
+              <a:rPr lang="en-GB" dirty="0" err="1"/>
+              <a:t>doi</a:t>
+            </a:r>
+            <a:r>
+              <a:rPr lang="en-GB" dirty="0"/>
+              <a:t>: 10.1109/ISIBER68248.2026.11470541.</a:t>
+            </a:r>
+          </a:p>
+          <a:p>
+            <a:r>
+              <a:rPr lang="en-GB" dirty="0"/>
+              <a:t>[3] J. Yang, “Automated essay scoring in education,” in </a:t>
+            </a:r>
+            <a:r>
+              <a:rPr lang="en-GB" i="1" dirty="0"/>
+              <a:t>2024 4th International Conference on Educational Technology (ICET)</a:t>
+            </a:r>
+            <a:r>
+              <a:rPr lang="en-GB" dirty="0"/>
+              <a:t>, 2024, </a:t>
+            </a:r>
+            <a:r>
+              <a:rPr lang="en-GB" dirty="0" err="1"/>
+              <a:t>doi</a:t>
+            </a:r>
+            <a:r>
+              <a:rPr lang="en-GB" dirty="0"/>
+              <a:t>: 10.1109/ICET62460.2024.10868446.</a:t>
+            </a:r>
+          </a:p>
+          <a:p>
+            <a:r>
+              <a:rPr lang="en-GB" dirty="0"/>
+              <a:t>[4] K. S. S. Han and M. T. Myint, “A comparative study of LSTM, Bi-LSTM, and BERT for automated essay scoring,” in </a:t>
+            </a:r>
+            <a:r>
+              <a:rPr lang="en-GB" i="1" dirty="0"/>
+              <a:t>2024 5th International Conference on Advanced Information Technologies (ICAIT)</a:t>
+            </a:r>
+            <a:r>
+              <a:rPr lang="en-GB" dirty="0"/>
+              <a:t>, 2024, </a:t>
+            </a:r>
+            <a:r>
+              <a:rPr lang="en-GB" dirty="0" err="1"/>
+              <a:t>doi</a:t>
+            </a:r>
+            <a:r>
+              <a:rPr lang="en-GB" dirty="0"/>
+              <a:t>: 10.1109/ICAIT65209.2024.10754925.</a:t>
+            </a:r>
+          </a:p>
+          <a:p>
+            <a:r>
+              <a:rPr lang="en-GB" dirty="0"/>
+              <a:t>[5] W. Xu, R. Mahmud, and W. L. Hoo, “A systematic literature review: Are automated essay scoring systems competent in real-life education scenarios?” </a:t>
+            </a:r>
+            <a:r>
+              <a:rPr lang="en-GB" i="1" dirty="0"/>
+              <a:t>IEEE Access</a:t>
+            </a:r>
+            <a:r>
+              <a:rPr lang="en-GB" dirty="0"/>
+              <a:t>, vol. 12, pp. 66959–66984, 2024, </a:t>
+            </a:r>
+            <a:r>
+              <a:rPr lang="en-GB" dirty="0" err="1"/>
+              <a:t>doi</a:t>
+            </a:r>
+            <a:r>
+              <a:rPr lang="en-GB" dirty="0"/>
+              <a:t>: 10.1109/ACCESS.2024.3399163.</a:t>
+            </a:r>
+          </a:p>
+          <a:p>
+            <a:r>
+              <a:rPr lang="en-GB" dirty="0"/>
+              <a:t>[6] A. M. </a:t>
+            </a:r>
+            <a:r>
+              <a:rPr lang="en-GB" dirty="0" err="1"/>
+              <a:t>Elmassry</a:t>
+            </a:r>
+            <a:r>
+              <a:rPr lang="en-GB" dirty="0"/>
+              <a:t>, N. Zaki, N. Alsheikh, and M. </a:t>
+            </a:r>
+            <a:r>
+              <a:rPr lang="en-GB" dirty="0" err="1"/>
+              <a:t>Mediani</a:t>
+            </a:r>
+            <a:r>
+              <a:rPr lang="en-GB" dirty="0"/>
+              <a:t>, “A systematic review of pretrained models in automated essay scoring,” </a:t>
+            </a:r>
+            <a:r>
+              <a:rPr lang="en-GB" i="1" dirty="0"/>
+              <a:t>IEEE Access</a:t>
+            </a:r>
+            <a:r>
+              <a:rPr lang="en-GB" dirty="0"/>
+              <a:t>, vol. 13, pp. 113245–113268, 2025, </a:t>
+            </a:r>
+            <a:r>
+              <a:rPr lang="en-GB" dirty="0" err="1"/>
+              <a:t>doi</a:t>
+            </a:r>
+            <a:r>
+              <a:rPr lang="en-GB" dirty="0"/>
+              <a:t>: 10.1109/ACCESS.2025.3584784.</a:t>
+            </a:r>
+          </a:p>
+          <a:p>
+            <a:r>
+              <a:rPr lang="en-GB" dirty="0"/>
+              <a:t>[7] Huang </a:t>
+            </a:r>
+            <a:r>
+              <a:rPr lang="en-GB" dirty="0" err="1"/>
+              <a:t>Chimingyang</a:t>
+            </a:r>
+            <a:r>
+              <a:rPr lang="en-GB" dirty="0"/>
+              <a:t>, “An Automatic System for Essay Questions Scoring Based on LSTM and Word Embedding,” in </a:t>
+            </a:r>
+            <a:r>
+              <a:rPr lang="en-GB" i="1" dirty="0"/>
+              <a:t>Proceedings of the 2020 5th International Conference on Information Science, Computer Technology and Transportation (ISCTT)</a:t>
+            </a:r>
+            <a:r>
+              <a:rPr lang="en-GB" dirty="0"/>
+              <a:t>, 2020, </a:t>
+            </a:r>
+            <a:r>
+              <a:rPr lang="en-GB" dirty="0" err="1"/>
+              <a:t>doi</a:t>
+            </a:r>
+            <a:r>
+              <a:rPr lang="en-GB" dirty="0"/>
+              <a:t>: 10.1109/ISCTT51595.2020.00068.</a:t>
+            </a:r>
+          </a:p>
+          <a:p>
+            <a:endParaRPr lang="en-GB" dirty="0"/>
+          </a:p>
+        </p:txBody>
+      </p:sp>
     </p:spTree>
     <p:extLst>
       <p:ext uri="{BB962C8B-B14F-4D97-AF65-F5344CB8AC3E}">
@@ -17126,7 +17672,7 @@
 </p:sld>
 </file>
 
-<file path=ppt/slides/slide7.xml><?xml version="1.0" encoding="utf-8"?>
+<file path=ppt/slides/slide8.xml><?xml version="1.0" encoding="utf-8"?>
 <p:sld xmlns:a="http://schemas.openxmlformats.org/drawingml/2006/main" xmlns:r="http://schemas.openxmlformats.org/officeDocument/2006/relationships" xmlns:p="http://schemas.openxmlformats.org/presentationml/2006/main">
   <p:cSld>
     <p:bg>

</xml_diff>